<commit_message>
Remove temporary PowerPoint file and update presentation README with enhanced slide details. Revise video script for improved timing and clarity, and adjust diagram generation scripts for better visual presentation. Update binary report file for dissertation Assignment2.
</commit_message>
<xml_diff>
--- a/docs/presentation/202440724_PPXAI_Presentation.pptx
+++ b/docs/presentation/202440724_PPXAI_Presentation.pptx
@@ -4541,7 +4541,7 @@
           <a:p>
             <a:pPr algn="l"/>
             <a:r>
-              <a:rPr sz="1400" b="1">
+              <a:rPr sz="1600" b="1">
                 <a:solidFill>
                   <a:srgbClr val="0D7377"/>
                 </a:solidFill>
@@ -4576,7 +4576,7 @@
           <a:p>
             <a:pPr algn="l"/>
             <a:r>
-              <a:rPr sz="3200" b="1">
+              <a:rPr sz="3400" b="1">
                 <a:solidFill>
                   <a:srgbClr val="2C3E50"/>
                 </a:solidFill>
@@ -4612,7 +4612,7 @@
           <a:p>
             <a:pPr algn="l"/>
             <a:r>
-              <a:rPr sz="1800" b="0">
+              <a:rPr sz="2000" b="0">
                 <a:solidFill>
                   <a:srgbClr val="5D6D7E"/>
                 </a:solidFill>
@@ -4647,7 +4647,7 @@
           <a:p>
             <a:pPr algn="l"/>
             <a:r>
-              <a:rPr sz="1600" b="0">
+              <a:rPr sz="1800" b="0">
                 <a:solidFill>
                   <a:srgbClr val="2C3E50"/>
                 </a:solidFill>
@@ -4683,7 +4683,7 @@
           <a:p>
             <a:pPr algn="l"/>
             <a:r>
-              <a:rPr sz="1000" b="0">
+              <a:rPr sz="1100" b="0">
                 <a:solidFill>
                   <a:srgbClr val="5D6D7E"/>
                 </a:solidFill>
@@ -4718,7 +4718,7 @@
           <a:p>
             <a:pPr algn="r"/>
             <a:r>
-              <a:rPr sz="1000" b="0">
+              <a:rPr sz="1100" b="0">
                 <a:solidFill>
                   <a:srgbClr val="5D6D7E"/>
                 </a:solidFill>
@@ -4814,7 +4814,7 @@
           <a:p>
             <a:pPr algn="l"/>
             <a:r>
-              <a:rPr sz="2400" b="1">
+              <a:rPr sz="2800" b="1">
                 <a:solidFill>
                   <a:srgbClr val="2C3E50"/>
                 </a:solidFill>
@@ -4849,11 +4849,11 @@
           <a:p>
             <a:pPr algn="l">
               <a:spcAft>
-                <a:spcPts val="1200"/>
+                <a:spcPts val="1400"/>
               </a:spcAft>
             </a:pPr>
             <a:r>
-              <a:rPr sz="1700" b="0">
+              <a:rPr sz="1900" b="0">
                 <a:solidFill>
                   <a:srgbClr val="2C3E50"/>
                 </a:solidFill>
@@ -4865,11 +4865,11 @@
           <a:p>
             <a:pPr algn="l">
               <a:spcAft>
-                <a:spcPts val="1200"/>
+                <a:spcPts val="1400"/>
               </a:spcAft>
             </a:pPr>
             <a:r>
-              <a:rPr sz="1700" b="0">
+              <a:rPr sz="1900" b="0">
                 <a:solidFill>
                   <a:srgbClr val="2C3E50"/>
                 </a:solidFill>
@@ -4881,11 +4881,11 @@
           <a:p>
             <a:pPr algn="l">
               <a:spcAft>
-                <a:spcPts val="1200"/>
+                <a:spcPts val="1400"/>
               </a:spcAft>
             </a:pPr>
             <a:r>
-              <a:rPr sz="1700" b="0">
+              <a:rPr sz="1900" b="0">
                 <a:solidFill>
                   <a:srgbClr val="2C3E50"/>
                 </a:solidFill>
@@ -4897,11 +4897,11 @@
           <a:p>
             <a:pPr algn="l">
               <a:spcAft>
-                <a:spcPts val="1200"/>
+                <a:spcPts val="1400"/>
               </a:spcAft>
             </a:pPr>
             <a:r>
-              <a:rPr sz="1700" b="0">
+              <a:rPr sz="1900" b="0">
                 <a:solidFill>
                   <a:srgbClr val="2C3E50"/>
                 </a:solidFill>
@@ -4913,11 +4913,11 @@
           <a:p>
             <a:pPr algn="l">
               <a:spcAft>
-                <a:spcPts val="1200"/>
+                <a:spcPts val="1400"/>
               </a:spcAft>
             </a:pPr>
             <a:r>
-              <a:rPr sz="1700" b="0">
+              <a:rPr sz="1900" b="0">
                 <a:solidFill>
                   <a:srgbClr val="2C3E50"/>
                 </a:solidFill>
@@ -4929,11 +4929,11 @@
           <a:p>
             <a:pPr algn="l">
               <a:spcAft>
-                <a:spcPts val="1200"/>
+                <a:spcPts val="1400"/>
               </a:spcAft>
             </a:pPr>
             <a:r>
-              <a:rPr sz="1700" b="0">
+              <a:rPr sz="1900" b="0">
                 <a:solidFill>
                   <a:srgbClr val="2C3E50"/>
                 </a:solidFill>
@@ -4968,7 +4968,7 @@
           <a:p>
             <a:pPr algn="l"/>
             <a:r>
-              <a:rPr sz="1000" b="0">
+              <a:rPr sz="1100" b="0">
                 <a:solidFill>
                   <a:srgbClr val="5D6D7E"/>
                 </a:solidFill>
@@ -5003,7 +5003,7 @@
           <a:p>
             <a:pPr algn="r"/>
             <a:r>
-              <a:rPr sz="1000" b="0">
+              <a:rPr sz="1100" b="0">
                 <a:solidFill>
                   <a:srgbClr val="5D6D7E"/>
                 </a:solidFill>
@@ -5099,7 +5099,7 @@
           <a:p>
             <a:pPr algn="l"/>
             <a:r>
-              <a:rPr sz="2200" b="1">
+              <a:rPr sz="2600" b="1">
                 <a:solidFill>
                   <a:srgbClr val="2C3E50"/>
                 </a:solidFill>
@@ -5182,7 +5182,7 @@
           <a:p>
             <a:pPr algn="l"/>
             <a:r>
-              <a:rPr sz="1200" b="0">
+              <a:rPr sz="1500" b="0">
                 <a:solidFill>
                   <a:srgbClr val="2C3E50"/>
                 </a:solidFill>
@@ -5217,7 +5217,7 @@
           <a:p>
             <a:pPr algn="l"/>
             <a:r>
-              <a:rPr sz="1000" b="0">
+              <a:rPr sz="1100" b="0">
                 <a:solidFill>
                   <a:srgbClr val="5D6D7E"/>
                 </a:solidFill>
@@ -5252,7 +5252,7 @@
           <a:p>
             <a:pPr algn="r"/>
             <a:r>
-              <a:rPr sz="1000" b="0">
+              <a:rPr sz="1100" b="0">
                 <a:solidFill>
                   <a:srgbClr val="5D6D7E"/>
                 </a:solidFill>
@@ -5348,7 +5348,7 @@
           <a:p>
             <a:pPr algn="l"/>
             <a:r>
-              <a:rPr sz="2600" b="1">
+              <a:rPr sz="2800" b="1">
                 <a:solidFill>
                   <a:srgbClr val="2C3E50"/>
                 </a:solidFill>
@@ -5383,11 +5383,11 @@
           <a:p>
             <a:pPr algn="l">
               <a:spcAft>
-                <a:spcPts val="1400"/>
+                <a:spcPts val="1600"/>
               </a:spcAft>
             </a:pPr>
             <a:r>
-              <a:rPr sz="1800" b="0">
+              <a:rPr sz="2000" b="0">
                 <a:solidFill>
                   <a:srgbClr val="2C3E50"/>
                 </a:solidFill>
@@ -5399,11 +5399,11 @@
           <a:p>
             <a:pPr algn="l">
               <a:spcAft>
-                <a:spcPts val="1400"/>
+                <a:spcPts val="1600"/>
               </a:spcAft>
             </a:pPr>
             <a:r>
-              <a:rPr sz="1800" b="0">
+              <a:rPr sz="2000" b="0">
                 <a:solidFill>
                   <a:srgbClr val="2C3E50"/>
                 </a:solidFill>
@@ -5415,11 +5415,11 @@
           <a:p>
             <a:pPr algn="l">
               <a:spcAft>
-                <a:spcPts val="1400"/>
+                <a:spcPts val="1600"/>
               </a:spcAft>
             </a:pPr>
             <a:r>
-              <a:rPr sz="1800" b="0">
+              <a:rPr sz="2000" b="0">
                 <a:solidFill>
                   <a:srgbClr val="2C3E50"/>
                 </a:solidFill>
@@ -5431,11 +5431,11 @@
           <a:p>
             <a:pPr algn="l">
               <a:spcAft>
-                <a:spcPts val="1400"/>
+                <a:spcPts val="1600"/>
               </a:spcAft>
             </a:pPr>
             <a:r>
-              <a:rPr sz="1800" b="0">
+              <a:rPr sz="2000" b="0">
                 <a:solidFill>
                   <a:srgbClr val="2C3E50"/>
                 </a:solidFill>
@@ -5447,11 +5447,11 @@
           <a:p>
             <a:pPr algn="l">
               <a:spcAft>
-                <a:spcPts val="1400"/>
+                <a:spcPts val="1600"/>
               </a:spcAft>
             </a:pPr>
             <a:r>
-              <a:rPr sz="1800" b="0">
+              <a:rPr sz="2000" b="0">
                 <a:solidFill>
                   <a:srgbClr val="2C3E50"/>
                 </a:solidFill>
@@ -5486,7 +5486,7 @@
           <a:p>
             <a:pPr algn="l"/>
             <a:r>
-              <a:rPr sz="1600" b="1">
+              <a:rPr sz="1800" b="1">
                 <a:solidFill>
                   <a:srgbClr val="0D7377"/>
                 </a:solidFill>
@@ -5521,7 +5521,7 @@
           <a:p>
             <a:pPr algn="l"/>
             <a:r>
-              <a:rPr sz="1000" b="0">
+              <a:rPr sz="1100" b="0">
                 <a:solidFill>
                   <a:srgbClr val="5D6D7E"/>
                 </a:solidFill>
@@ -5556,7 +5556,7 @@
           <a:p>
             <a:pPr algn="r"/>
             <a:r>
-              <a:rPr sz="1000" b="0">
+              <a:rPr sz="1100" b="0">
                 <a:solidFill>
                   <a:srgbClr val="5D6D7E"/>
                 </a:solidFill>
@@ -5652,7 +5652,7 @@
           <a:p>
             <a:pPr algn="l"/>
             <a:r>
-              <a:rPr sz="2600" b="1">
+              <a:rPr sz="2800" b="1">
                 <a:solidFill>
                   <a:srgbClr val="2C3E50"/>
                 </a:solidFill>
@@ -5687,11 +5687,11 @@
           <a:p>
             <a:pPr algn="l">
               <a:spcAft>
-                <a:spcPts val="1000"/>
+                <a:spcPts val="1200"/>
               </a:spcAft>
             </a:pPr>
             <a:r>
-              <a:rPr sz="1600" b="0">
+              <a:rPr sz="1800" b="0">
                 <a:solidFill>
                   <a:srgbClr val="2C3E50"/>
                 </a:solidFill>
@@ -5703,11 +5703,11 @@
           <a:p>
             <a:pPr algn="l">
               <a:spcAft>
-                <a:spcPts val="1000"/>
+                <a:spcPts val="1200"/>
               </a:spcAft>
             </a:pPr>
             <a:r>
-              <a:rPr sz="1600" b="0">
+              <a:rPr sz="1800" b="0">
                 <a:solidFill>
                   <a:srgbClr val="2C3E50"/>
                 </a:solidFill>
@@ -5719,11 +5719,11 @@
           <a:p>
             <a:pPr algn="l">
               <a:spcAft>
-                <a:spcPts val="1000"/>
+                <a:spcPts val="1200"/>
               </a:spcAft>
             </a:pPr>
             <a:r>
-              <a:rPr sz="1600" b="0">
+              <a:rPr sz="1800" b="0">
                 <a:solidFill>
                   <a:srgbClr val="2C3E50"/>
                 </a:solidFill>
@@ -5735,11 +5735,11 @@
           <a:p>
             <a:pPr algn="l">
               <a:spcAft>
-                <a:spcPts val="1000"/>
+                <a:spcPts val="1200"/>
               </a:spcAft>
             </a:pPr>
             <a:r>
-              <a:rPr sz="1600" b="0">
+              <a:rPr sz="1800" b="0">
                 <a:solidFill>
                   <a:srgbClr val="2C3E50"/>
                 </a:solidFill>
@@ -5751,11 +5751,11 @@
           <a:p>
             <a:pPr algn="l">
               <a:spcAft>
-                <a:spcPts val="1000"/>
+                <a:spcPts val="1200"/>
               </a:spcAft>
             </a:pPr>
             <a:r>
-              <a:rPr sz="1600" b="0">
+              <a:rPr sz="1800" b="0">
                 <a:solidFill>
                   <a:srgbClr val="2C3E50"/>
                 </a:solidFill>
@@ -5767,11 +5767,11 @@
           <a:p>
             <a:pPr algn="l">
               <a:spcAft>
-                <a:spcPts val="1000"/>
+                <a:spcPts val="1200"/>
               </a:spcAft>
             </a:pPr>
             <a:r>
-              <a:rPr sz="1600" b="0">
+              <a:rPr sz="1800" b="0">
                 <a:solidFill>
                   <a:srgbClr val="2C3E50"/>
                 </a:solidFill>
@@ -5806,7 +5806,7 @@
           <a:p>
             <a:pPr algn="l"/>
             <a:r>
-              <a:rPr sz="1000" b="0">
+              <a:rPr sz="1100" b="0">
                 <a:solidFill>
                   <a:srgbClr val="5D6D7E"/>
                 </a:solidFill>
@@ -5841,7 +5841,7 @@
           <a:p>
             <a:pPr algn="r"/>
             <a:r>
-              <a:rPr sz="1000" b="0">
+              <a:rPr sz="1100" b="0">
                 <a:solidFill>
                   <a:srgbClr val="5D6D7E"/>
                 </a:solidFill>
@@ -5937,7 +5937,7 @@
           <a:p>
             <a:pPr algn="l"/>
             <a:r>
-              <a:rPr sz="2400" b="1">
+              <a:rPr sz="2800" b="1">
                 <a:solidFill>
                   <a:srgbClr val="2C3E50"/>
                 </a:solidFill>
@@ -5972,11 +5972,11 @@
           <a:p>
             <a:pPr algn="l">
               <a:spcAft>
-                <a:spcPts val="1000"/>
+                <a:spcPts val="1200"/>
               </a:spcAft>
             </a:pPr>
             <a:r>
-              <a:rPr sz="1600" b="0">
+              <a:rPr sz="1800" b="0">
                 <a:solidFill>
                   <a:srgbClr val="2C3E50"/>
                 </a:solidFill>
@@ -5988,11 +5988,11 @@
           <a:p>
             <a:pPr algn="l">
               <a:spcAft>
-                <a:spcPts val="1000"/>
+                <a:spcPts val="1200"/>
               </a:spcAft>
             </a:pPr>
             <a:r>
-              <a:rPr sz="1600" b="0">
+              <a:rPr sz="1800" b="0">
                 <a:solidFill>
                   <a:srgbClr val="2C3E50"/>
                 </a:solidFill>
@@ -6004,11 +6004,11 @@
           <a:p>
             <a:pPr algn="l">
               <a:spcAft>
-                <a:spcPts val="1000"/>
+                <a:spcPts val="1200"/>
               </a:spcAft>
             </a:pPr>
             <a:r>
-              <a:rPr sz="1600" b="0">
+              <a:rPr sz="1800" b="0">
                 <a:solidFill>
                   <a:srgbClr val="2C3E50"/>
                 </a:solidFill>
@@ -6020,11 +6020,11 @@
           <a:p>
             <a:pPr algn="l">
               <a:spcAft>
-                <a:spcPts val="1000"/>
+                <a:spcPts val="1200"/>
               </a:spcAft>
             </a:pPr>
             <a:r>
-              <a:rPr sz="1600" b="0">
+              <a:rPr sz="1800" b="0">
                 <a:solidFill>
                   <a:srgbClr val="2C3E50"/>
                 </a:solidFill>
@@ -6036,11 +6036,11 @@
           <a:p>
             <a:pPr algn="l">
               <a:spcAft>
-                <a:spcPts val="1000"/>
+                <a:spcPts val="1200"/>
               </a:spcAft>
             </a:pPr>
             <a:r>
-              <a:rPr sz="1600" b="0">
+              <a:rPr sz="1800" b="0">
                 <a:solidFill>
                   <a:srgbClr val="2C3E50"/>
                 </a:solidFill>
@@ -6075,7 +6075,7 @@
           <a:p>
             <a:pPr algn="ctr"/>
             <a:r>
-              <a:rPr sz="2200" b="1">
+              <a:rPr sz="2400" b="1">
                 <a:solidFill>
                   <a:srgbClr val="0D7377"/>
                 </a:solidFill>
@@ -6110,7 +6110,7 @@
           <a:p>
             <a:pPr algn="ctr"/>
             <a:r>
-              <a:rPr sz="1100" b="0">
+              <a:rPr sz="1300" b="0">
                 <a:solidFill>
                   <a:srgbClr val="5D6D7E"/>
                 </a:solidFill>
@@ -6145,7 +6145,7 @@
           <a:p>
             <a:pPr algn="l"/>
             <a:r>
-              <a:rPr sz="1000" b="0">
+              <a:rPr sz="1100" b="0">
                 <a:solidFill>
                   <a:srgbClr val="5D6D7E"/>
                 </a:solidFill>
@@ -6180,7 +6180,7 @@
           <a:p>
             <a:pPr algn="r"/>
             <a:r>
-              <a:rPr sz="1000" b="0">
+              <a:rPr sz="1100" b="0">
                 <a:solidFill>
                   <a:srgbClr val="5D6D7E"/>
                 </a:solidFill>
@@ -6276,7 +6276,7 @@
           <a:p>
             <a:pPr algn="l"/>
             <a:r>
-              <a:rPr sz="2800" b="1">
+              <a:rPr sz="3000" b="1">
                 <a:solidFill>
                   <a:srgbClr val="2C3E50"/>
                 </a:solidFill>
@@ -6311,11 +6311,11 @@
           <a:p>
             <a:pPr algn="l">
               <a:spcAft>
-                <a:spcPts val="1200"/>
+                <a:spcPts val="1400"/>
               </a:spcAft>
             </a:pPr>
             <a:r>
-              <a:rPr sz="1700" b="0">
+              <a:rPr sz="1900" b="0">
                 <a:solidFill>
                   <a:srgbClr val="2C3E50"/>
                 </a:solidFill>
@@ -6327,11 +6327,11 @@
           <a:p>
             <a:pPr algn="l">
               <a:spcAft>
-                <a:spcPts val="1200"/>
+                <a:spcPts val="1400"/>
               </a:spcAft>
             </a:pPr>
             <a:r>
-              <a:rPr sz="1700" b="0">
+              <a:rPr sz="1900" b="0">
                 <a:solidFill>
                   <a:srgbClr val="2C3E50"/>
                 </a:solidFill>
@@ -6343,11 +6343,11 @@
           <a:p>
             <a:pPr algn="l">
               <a:spcAft>
-                <a:spcPts val="1200"/>
+                <a:spcPts val="1400"/>
               </a:spcAft>
             </a:pPr>
             <a:r>
-              <a:rPr sz="1700" b="0">
+              <a:rPr sz="1900" b="0">
                 <a:solidFill>
                   <a:srgbClr val="2C3E50"/>
                 </a:solidFill>
@@ -6359,11 +6359,11 @@
           <a:p>
             <a:pPr algn="l">
               <a:spcAft>
-                <a:spcPts val="1200"/>
+                <a:spcPts val="1400"/>
               </a:spcAft>
             </a:pPr>
             <a:r>
-              <a:rPr sz="1700" b="0">
+              <a:rPr sz="1900" b="0">
                 <a:solidFill>
                   <a:srgbClr val="2C3E50"/>
                 </a:solidFill>
@@ -6375,11 +6375,11 @@
           <a:p>
             <a:pPr algn="l">
               <a:spcAft>
-                <a:spcPts val="1200"/>
+                <a:spcPts val="1400"/>
               </a:spcAft>
             </a:pPr>
             <a:r>
-              <a:rPr sz="1700" b="0">
+              <a:rPr sz="1900" b="0">
                 <a:solidFill>
                   <a:srgbClr val="2C3E50"/>
                 </a:solidFill>
@@ -6407,7 +6407,7 @@
         <p:spPr>
           <a:xfrm>
             <a:off x="6400800" y="914400"/>
-            <a:ext cx="5303520" cy="4196722"/>
+            <a:ext cx="5303520" cy="5271762"/>
           </a:xfrm>
           <a:prstGeom prst="rect">
             <a:avLst/>
@@ -6438,7 +6438,7 @@
           <a:p>
             <a:pPr algn="l"/>
             <a:r>
-              <a:rPr sz="1000" b="0">
+              <a:rPr sz="1100" b="0">
                 <a:solidFill>
                   <a:srgbClr val="5D6D7E"/>
                 </a:solidFill>
@@ -6473,7 +6473,7 @@
           <a:p>
             <a:pPr algn="r"/>
             <a:r>
-              <a:rPr sz="1000" b="0">
+              <a:rPr sz="1100" b="0">
                 <a:solidFill>
                   <a:srgbClr val="5D6D7E"/>
                 </a:solidFill>
@@ -6569,7 +6569,7 @@
           <a:p>
             <a:pPr algn="l"/>
             <a:r>
-              <a:rPr sz="2600" b="1">
+              <a:rPr sz="2800" b="1">
                 <a:solidFill>
                   <a:srgbClr val="2C3E50"/>
                 </a:solidFill>
@@ -6604,7 +6604,7 @@
           <a:p>
             <a:pPr algn="l"/>
             <a:r>
-              <a:rPr sz="1500" b="0">
+              <a:rPr sz="1800" b="0">
                 <a:solidFill>
                   <a:srgbClr val="2C3E50"/>
                 </a:solidFill>
@@ -6639,11 +6639,11 @@
           <a:p>
             <a:pPr algn="l">
               <a:spcAft>
-                <a:spcPts val="1000"/>
+                <a:spcPts val="1200"/>
               </a:spcAft>
             </a:pPr>
             <a:r>
-              <a:rPr sz="1600" b="0">
+              <a:rPr sz="1800" b="0">
                 <a:solidFill>
                   <a:srgbClr val="2C3E50"/>
                 </a:solidFill>
@@ -6655,11 +6655,11 @@
           <a:p>
             <a:pPr algn="l">
               <a:spcAft>
-                <a:spcPts val="1000"/>
+                <a:spcPts val="1200"/>
               </a:spcAft>
             </a:pPr>
             <a:r>
-              <a:rPr sz="1600" b="0">
+              <a:rPr sz="1800" b="0">
                 <a:solidFill>
                   <a:srgbClr val="2C3E50"/>
                 </a:solidFill>
@@ -6671,11 +6671,11 @@
           <a:p>
             <a:pPr algn="l">
               <a:spcAft>
-                <a:spcPts val="1000"/>
+                <a:spcPts val="1200"/>
               </a:spcAft>
             </a:pPr>
             <a:r>
-              <a:rPr sz="1600" b="0">
+              <a:rPr sz="1800" b="0">
                 <a:solidFill>
                   <a:srgbClr val="2C3E50"/>
                 </a:solidFill>
@@ -6687,11 +6687,11 @@
           <a:p>
             <a:pPr algn="l">
               <a:spcAft>
-                <a:spcPts val="1000"/>
+                <a:spcPts val="1200"/>
               </a:spcAft>
             </a:pPr>
             <a:r>
-              <a:rPr sz="1600" b="0">
+              <a:rPr sz="1800" b="0">
                 <a:solidFill>
                   <a:srgbClr val="2C3E50"/>
                 </a:solidFill>
@@ -6703,11 +6703,11 @@
           <a:p>
             <a:pPr algn="l">
               <a:spcAft>
-                <a:spcPts val="1000"/>
+                <a:spcPts val="1200"/>
               </a:spcAft>
             </a:pPr>
             <a:r>
-              <a:rPr sz="1600" b="0">
+              <a:rPr sz="1800" b="0">
                 <a:solidFill>
                   <a:srgbClr val="2C3E50"/>
                 </a:solidFill>
@@ -6742,7 +6742,7 @@
           <a:p>
             <a:pPr algn="l"/>
             <a:r>
-              <a:rPr sz="1000" b="0">
+              <a:rPr sz="1100" b="0">
                 <a:solidFill>
                   <a:srgbClr val="5D6D7E"/>
                 </a:solidFill>
@@ -6777,7 +6777,7 @@
           <a:p>
             <a:pPr algn="r"/>
             <a:r>
-              <a:rPr sz="1000" b="0">
+              <a:rPr sz="1100" b="0">
                 <a:solidFill>
                   <a:srgbClr val="5D6D7E"/>
                 </a:solidFill>
@@ -6873,7 +6873,7 @@
           <a:p>
             <a:pPr algn="l"/>
             <a:r>
-              <a:rPr sz="2400" b="1">
+              <a:rPr sz="2800" b="1">
                 <a:solidFill>
                   <a:srgbClr val="2C3E50"/>
                 </a:solidFill>
@@ -6932,7 +6932,7 @@
           <a:p>
             <a:pPr algn="l"/>
             <a:r>
-              <a:rPr sz="1000" b="0">
+              <a:rPr sz="1100" b="0">
                 <a:solidFill>
                   <a:srgbClr val="5D6D7E"/>
                 </a:solidFill>
@@ -6967,7 +6967,7 @@
           <a:p>
             <a:pPr algn="r"/>
             <a:r>
-              <a:rPr sz="1000" b="0">
+              <a:rPr sz="1100" b="0">
                 <a:solidFill>
                   <a:srgbClr val="5D6D7E"/>
                 </a:solidFill>
@@ -7063,7 +7063,7 @@
           <a:p>
             <a:pPr algn="l"/>
             <a:r>
-              <a:rPr sz="2600" b="1">
+              <a:rPr sz="2800" b="1">
                 <a:solidFill>
                   <a:srgbClr val="2C3E50"/>
                 </a:solidFill>
@@ -7098,11 +7098,11 @@
           <a:p>
             <a:pPr algn="l">
               <a:spcAft>
-                <a:spcPts val="800"/>
+                <a:spcPts val="1000"/>
               </a:spcAft>
             </a:pPr>
             <a:r>
-              <a:rPr sz="1500" b="0">
+              <a:rPr sz="1700" b="0">
                 <a:solidFill>
                   <a:srgbClr val="2C3E50"/>
                 </a:solidFill>
@@ -7114,11 +7114,11 @@
           <a:p>
             <a:pPr algn="l">
               <a:spcAft>
-                <a:spcPts val="800"/>
+                <a:spcPts val="1000"/>
               </a:spcAft>
             </a:pPr>
             <a:r>
-              <a:rPr sz="1500" b="0">
+              <a:rPr sz="1700" b="0">
                 <a:solidFill>
                   <a:srgbClr val="2C3E50"/>
                 </a:solidFill>
@@ -7130,11 +7130,11 @@
           <a:p>
             <a:pPr algn="l">
               <a:spcAft>
-                <a:spcPts val="800"/>
+                <a:spcPts val="1000"/>
               </a:spcAft>
             </a:pPr>
             <a:r>
-              <a:rPr sz="1500" b="0">
+              <a:rPr sz="1700" b="0">
                 <a:solidFill>
                   <a:srgbClr val="2C3E50"/>
                 </a:solidFill>
@@ -7146,11 +7146,11 @@
           <a:p>
             <a:pPr algn="l">
               <a:spcAft>
-                <a:spcPts val="800"/>
+                <a:spcPts val="1000"/>
               </a:spcAft>
             </a:pPr>
             <a:r>
-              <a:rPr sz="1500" b="0">
+              <a:rPr sz="1700" b="0">
                 <a:solidFill>
                   <a:srgbClr val="2C3E50"/>
                 </a:solidFill>
@@ -7162,11 +7162,11 @@
           <a:p>
             <a:pPr algn="l">
               <a:spcAft>
-                <a:spcPts val="800"/>
+                <a:spcPts val="1000"/>
               </a:spcAft>
             </a:pPr>
             <a:r>
-              <a:rPr sz="1500" b="0">
+              <a:rPr sz="1700" b="0">
                 <a:solidFill>
                   <a:srgbClr val="2C3E50"/>
                 </a:solidFill>
@@ -7178,11 +7178,11 @@
           <a:p>
             <a:pPr algn="l">
               <a:spcAft>
-                <a:spcPts val="800"/>
+                <a:spcPts val="1000"/>
               </a:spcAft>
             </a:pPr>
             <a:r>
-              <a:rPr sz="1500" b="0">
+              <a:rPr sz="1700" b="0">
                 <a:solidFill>
                   <a:srgbClr val="2C3E50"/>
                 </a:solidFill>
@@ -7194,11 +7194,11 @@
           <a:p>
             <a:pPr algn="l">
               <a:spcAft>
-                <a:spcPts val="800"/>
+                <a:spcPts val="1000"/>
               </a:spcAft>
             </a:pPr>
             <a:r>
-              <a:rPr sz="1500" b="0">
+              <a:rPr sz="1700" b="0">
                 <a:solidFill>
                   <a:srgbClr val="2C3E50"/>
                 </a:solidFill>
@@ -7281,7 +7281,7 @@
           <a:p>
             <a:pPr algn="l"/>
             <a:r>
-              <a:rPr sz="1000" b="0">
+              <a:rPr sz="1100" b="0">
                 <a:solidFill>
                   <a:srgbClr val="5D6D7E"/>
                 </a:solidFill>
@@ -7316,7 +7316,7 @@
           <a:p>
             <a:pPr algn="r"/>
             <a:r>
-              <a:rPr sz="1000" b="0">
+              <a:rPr sz="1100" b="0">
                 <a:solidFill>
                   <a:srgbClr val="5D6D7E"/>
                 </a:solidFill>
@@ -7412,7 +7412,7 @@
           <a:p>
             <a:pPr algn="l"/>
             <a:r>
-              <a:rPr sz="2400" b="1">
+              <a:rPr sz="2800" b="1">
                 <a:solidFill>
                   <a:srgbClr val="2C3E50"/>
                 </a:solidFill>
@@ -7471,7 +7471,7 @@
           <a:p>
             <a:pPr algn="l"/>
             <a:r>
-              <a:rPr sz="1000" b="0">
+              <a:rPr sz="1100" b="0">
                 <a:solidFill>
                   <a:srgbClr val="5D6D7E"/>
                 </a:solidFill>
@@ -7506,7 +7506,7 @@
           <a:p>
             <a:pPr algn="r"/>
             <a:r>
-              <a:rPr sz="1000" b="0">
+              <a:rPr sz="1100" b="0">
                 <a:solidFill>
                   <a:srgbClr val="5D6D7E"/>
                 </a:solidFill>
@@ -7602,7 +7602,7 @@
           <a:p>
             <a:pPr algn="l"/>
             <a:r>
-              <a:rPr sz="2400" b="1">
+              <a:rPr sz="2800" b="1">
                 <a:solidFill>
                   <a:srgbClr val="2C3E50"/>
                 </a:solidFill>
@@ -7685,7 +7685,7 @@
           <a:p>
             <a:pPr algn="l"/>
             <a:r>
-              <a:rPr sz="1200" b="0">
+              <a:rPr sz="1500" b="0">
                 <a:solidFill>
                   <a:srgbClr val="5D6D7E"/>
                 </a:solidFill>
@@ -7720,7 +7720,7 @@
           <a:p>
             <a:pPr algn="l"/>
             <a:r>
-              <a:rPr sz="1000" b="0">
+              <a:rPr sz="1100" b="0">
                 <a:solidFill>
                   <a:srgbClr val="5D6D7E"/>
                 </a:solidFill>
@@ -7755,7 +7755,7 @@
           <a:p>
             <a:pPr algn="r"/>
             <a:r>
-              <a:rPr sz="1000" b="0">
+              <a:rPr sz="1100" b="0">
                 <a:solidFill>
                   <a:srgbClr val="5D6D7E"/>
                 </a:solidFill>
@@ -7851,7 +7851,7 @@
           <a:p>
             <a:pPr algn="l"/>
             <a:r>
-              <a:rPr sz="2400" b="1">
+              <a:rPr sz="2800" b="1">
                 <a:solidFill>
                   <a:srgbClr val="2C3E50"/>
                 </a:solidFill>
@@ -7934,7 +7934,7 @@
           <a:p>
             <a:pPr algn="l"/>
             <a:r>
-              <a:rPr sz="1300" b="0">
+              <a:rPr sz="1600" b="0">
                 <a:solidFill>
                   <a:srgbClr val="2C3E50"/>
                 </a:solidFill>
@@ -7969,7 +7969,7 @@
           <a:p>
             <a:pPr algn="l"/>
             <a:r>
-              <a:rPr sz="1000" b="0">
+              <a:rPr sz="1100" b="0">
                 <a:solidFill>
                   <a:srgbClr val="5D6D7E"/>
                 </a:solidFill>
@@ -8004,7 +8004,7 @@
           <a:p>
             <a:pPr algn="r"/>
             <a:r>
-              <a:rPr sz="1000" b="0">
+              <a:rPr sz="1100" b="0">
                 <a:solidFill>
                   <a:srgbClr val="5D6D7E"/>
                 </a:solidFill>
@@ -8100,7 +8100,7 @@
           <a:p>
             <a:pPr algn="l"/>
             <a:r>
-              <a:rPr sz="2200" b="1">
+              <a:rPr sz="2600" b="1">
                 <a:solidFill>
                   <a:srgbClr val="2C3E50"/>
                 </a:solidFill>
@@ -8183,7 +8183,7 @@
           <a:p>
             <a:pPr algn="l"/>
             <a:r>
-              <a:rPr sz="1300" b="0">
+              <a:rPr sz="1600" b="0">
                 <a:solidFill>
                   <a:srgbClr val="2C3E50"/>
                 </a:solidFill>
@@ -8218,7 +8218,7 @@
           <a:p>
             <a:pPr algn="l"/>
             <a:r>
-              <a:rPr sz="1000" b="0">
+              <a:rPr sz="1100" b="0">
                 <a:solidFill>
                   <a:srgbClr val="5D6D7E"/>
                 </a:solidFill>
@@ -8253,7 +8253,7 @@
           <a:p>
             <a:pPr algn="r"/>
             <a:r>
-              <a:rPr sz="1000" b="0">
+              <a:rPr sz="1100" b="0">
                 <a:solidFill>
                   <a:srgbClr val="5D6D7E"/>
                 </a:solidFill>

</xml_diff>